<commit_message>
Doc: condense pitch deck to strictly 8 slides on app, pptx presentation, and docs to comply with hackathon rules
</commit_message>
<xml_diff>
--- a/LaunchMind_PitchDeck.pptx
+++ b/LaunchMind_PitchDeck.pptx
@@ -13,11 +13,6 @@
     <p:sldId id="261" r:id="rId13"/>
     <p:sldId id="262" r:id="rId14"/>
     <p:sldId id="263" r:id="rId15"/>
-    <p:sldId id="264" r:id="rId16"/>
-    <p:sldId id="265" r:id="rId17"/>
-    <p:sldId id="266" r:id="rId18"/>
-    <p:sldId id="267" r:id="rId19"/>
-    <p:sldId id="268" r:id="rId20"/>
   </p:sldIdLst>
   <p:sldSz cx="12191695" cy="6858000" type="screen4x3"/>
   <p:notesSz cx="6858000" cy="9144000"/>
@@ -539,286 +534,6 @@
 </p:notes>
 </file>
 
-<file path=ppt/notesSlides/notesSlide10.xml><?xml version="1.0" encoding="utf-8"?>
-<p:notes xmlns:a="http://schemas.openxmlformats.org/drawingml/2006/main" xmlns:p="http://schemas.openxmlformats.org/presentationml/2006/main" xmlns:r="http://schemas.openxmlformats.org/officeDocument/2006/relationships">
-  <p:cSld>
-    <p:spTree>
-      <p:nvGrpSpPr>
-        <p:cNvPr id="1" name=""/>
-        <p:cNvGrpSpPr/>
-        <p:nvPr/>
-      </p:nvGrpSpPr>
-      <p:grpSpPr>
-        <a:xfrm>
-          <a:off x="0" y="0"/>
-          <a:ext cx="0" cy="0"/>
-          <a:chOff x="0" y="0"/>
-          <a:chExt cx="0" cy="0"/>
-        </a:xfrm>
-      </p:grpSpPr>
-      <p:sp>
-        <p:nvSpPr>
-          <p:cNvPr id="2" name="Slide Image Placeholder 1"/>
-          <p:cNvSpPr>
-            <a:spLocks noGrp="1"/>
-          </p:cNvSpPr>
-          <p:nvPr>
-            <p:ph type="sldImg" idx="2"/>
-          </p:nvPr>
-        </p:nvSpPr>
-        <p:spPr/>
-      </p:sp>
-      <p:sp>
-        <p:nvSpPr>
-          <p:cNvPr id="3" name="Notes Placeholder 2"/>
-          <p:cNvSpPr>
-            <a:spLocks noGrp="1"/>
-          </p:cNvSpPr>
-          <p:nvPr>
-            <p:ph type="body" idx="3" sz="quarter"/>
-          </p:nvPr>
-        </p:nvSpPr>
-        <p:spPr/>
-        <p:txBody>
-          <a:bodyPr/>
-          <a:lstStyle/>
-          <a:p>
-            <a:r>
-              <a:t>We're looking to integrate with hackathons and incubators to help founders test assumptions before spending code resources.</a:t>
-            </a:r>
-          </a:p>
-        </p:txBody>
-      </p:sp>
-      <p:sp>
-        <p:nvSpPr>
-          <p:cNvPr id="4" name="Slide Number Placeholder 3"/>
-          <p:cNvSpPr>
-            <a:spLocks noGrp="1"/>
-          </p:cNvSpPr>
-          <p:nvPr>
-            <p:ph type="sldNum" idx="5" sz="quarter"/>
-          </p:nvPr>
-        </p:nvSpPr>
-        <p:spPr/>
-      </p:sp>
-    </p:spTree>
-  </p:cSld>
-  <p:clrMapOvr>
-    <a:masterClrMapping/>
-  </p:clrMapOvr>
-</p:notes>
-</file>
-
-<file path=ppt/notesSlides/notesSlide11.xml><?xml version="1.0" encoding="utf-8"?>
-<p:notes xmlns:a="http://schemas.openxmlformats.org/drawingml/2006/main" xmlns:p="http://schemas.openxmlformats.org/presentationml/2006/main" xmlns:r="http://schemas.openxmlformats.org/officeDocument/2006/relationships">
-  <p:cSld>
-    <p:spTree>
-      <p:nvGrpSpPr>
-        <p:cNvPr id="1" name=""/>
-        <p:cNvGrpSpPr/>
-        <p:nvPr/>
-      </p:nvGrpSpPr>
-      <p:grpSpPr>
-        <a:xfrm>
-          <a:off x="0" y="0"/>
-          <a:ext cx="0" cy="0"/>
-          <a:chOff x="0" y="0"/>
-          <a:chExt cx="0" cy="0"/>
-        </a:xfrm>
-      </p:grpSpPr>
-      <p:sp>
-        <p:nvSpPr>
-          <p:cNvPr id="2" name="Slide Image Placeholder 1"/>
-          <p:cNvSpPr>
-            <a:spLocks noGrp="1"/>
-          </p:cNvSpPr>
-          <p:nvPr>
-            <p:ph type="sldImg" idx="2"/>
-          </p:nvPr>
-        </p:nvSpPr>
-        <p:spPr/>
-      </p:sp>
-      <p:sp>
-        <p:nvSpPr>
-          <p:cNvPr id="3" name="Notes Placeholder 2"/>
-          <p:cNvSpPr>
-            <a:spLocks noGrp="1"/>
-          </p:cNvSpPr>
-          <p:nvPr>
-            <p:ph type="body" idx="3" sz="quarter"/>
-          </p:nvPr>
-        </p:nvSpPr>
-        <p:spPr/>
-        <p:txBody>
-          <a:bodyPr/>
-          <a:lstStyle/>
-          <a:p>
-            <a:r>
-              <a:t>We monetize through a premium subscription for power creators, and enterprise packages for incubators.</a:t>
-            </a:r>
-          </a:p>
-        </p:txBody>
-      </p:sp>
-      <p:sp>
-        <p:nvSpPr>
-          <p:cNvPr id="4" name="Slide Number Placeholder 3"/>
-          <p:cNvSpPr>
-            <a:spLocks noGrp="1"/>
-          </p:cNvSpPr>
-          <p:nvPr>
-            <p:ph type="sldNum" idx="5" sz="quarter"/>
-          </p:nvPr>
-        </p:nvSpPr>
-        <p:spPr/>
-      </p:sp>
-    </p:spTree>
-  </p:cSld>
-  <p:clrMapOvr>
-    <a:masterClrMapping/>
-  </p:clrMapOvr>
-</p:notes>
-</file>
-
-<file path=ppt/notesSlides/notesSlide12.xml><?xml version="1.0" encoding="utf-8"?>
-<p:notes xmlns:a="http://schemas.openxmlformats.org/drawingml/2006/main" xmlns:p="http://schemas.openxmlformats.org/presentationml/2006/main" xmlns:r="http://schemas.openxmlformats.org/officeDocument/2006/relationships">
-  <p:cSld>
-    <p:spTree>
-      <p:nvGrpSpPr>
-        <p:cNvPr id="1" name=""/>
-        <p:cNvGrpSpPr/>
-        <p:nvPr/>
-      </p:nvGrpSpPr>
-      <p:grpSpPr>
-        <a:xfrm>
-          <a:off x="0" y="0"/>
-          <a:ext cx="0" cy="0"/>
-          <a:chOff x="0" y="0"/>
-          <a:chExt cx="0" cy="0"/>
-        </a:xfrm>
-      </p:grpSpPr>
-      <p:sp>
-        <p:nvSpPr>
-          <p:cNvPr id="2" name="Slide Image Placeholder 1"/>
-          <p:cNvSpPr>
-            <a:spLocks noGrp="1"/>
-          </p:cNvSpPr>
-          <p:nvPr>
-            <p:ph type="sldImg" idx="2"/>
-          </p:nvPr>
-        </p:nvSpPr>
-        <p:spPr/>
-      </p:sp>
-      <p:sp>
-        <p:nvSpPr>
-          <p:cNvPr id="3" name="Notes Placeholder 2"/>
-          <p:cNvSpPr>
-            <a:spLocks noGrp="1"/>
-          </p:cNvSpPr>
-          <p:nvPr>
-            <p:ph type="body" idx="3" sz="quarter"/>
-          </p:nvPr>
-        </p:nvSpPr>
-        <p:spPr/>
-        <p:txBody>
-          <a:bodyPr/>
-          <a:lstStyle/>
-          <a:p>
-            <a:r>
-              <a:t>Our GTM puts LaunchMind right where developers start — hackathons, repository creation, and early application portals.</a:t>
-            </a:r>
-          </a:p>
-        </p:txBody>
-      </p:sp>
-      <p:sp>
-        <p:nvSpPr>
-          <p:cNvPr id="4" name="Slide Number Placeholder 3"/>
-          <p:cNvSpPr>
-            <a:spLocks noGrp="1"/>
-          </p:cNvSpPr>
-          <p:nvPr>
-            <p:ph type="sldNum" idx="5" sz="quarter"/>
-          </p:nvPr>
-        </p:nvSpPr>
-        <p:spPr/>
-      </p:sp>
-    </p:spTree>
-  </p:cSld>
-  <p:clrMapOvr>
-    <a:masterClrMapping/>
-  </p:clrMapOvr>
-</p:notes>
-</file>
-
-<file path=ppt/notesSlides/notesSlide13.xml><?xml version="1.0" encoding="utf-8"?>
-<p:notes xmlns:a="http://schemas.openxmlformats.org/drawingml/2006/main" xmlns:p="http://schemas.openxmlformats.org/presentationml/2006/main" xmlns:r="http://schemas.openxmlformats.org/officeDocument/2006/relationships">
-  <p:cSld>
-    <p:spTree>
-      <p:nvGrpSpPr>
-        <p:cNvPr id="1" name=""/>
-        <p:cNvGrpSpPr/>
-        <p:nvPr/>
-      </p:nvGrpSpPr>
-      <p:grpSpPr>
-        <a:xfrm>
-          <a:off x="0" y="0"/>
-          <a:ext cx="0" cy="0"/>
-          <a:chOff x="0" y="0"/>
-          <a:chExt cx="0" cy="0"/>
-        </a:xfrm>
-      </p:grpSpPr>
-      <p:sp>
-        <p:nvSpPr>
-          <p:cNvPr id="2" name="Slide Image Placeholder 1"/>
-          <p:cNvSpPr>
-            <a:spLocks noGrp="1"/>
-          </p:cNvSpPr>
-          <p:nvPr>
-            <p:ph type="sldImg" idx="2"/>
-          </p:nvPr>
-        </p:nvSpPr>
-        <p:spPr/>
-      </p:sp>
-      <p:sp>
-        <p:nvSpPr>
-          <p:cNvPr id="3" name="Notes Placeholder 2"/>
-          <p:cNvSpPr>
-            <a:spLocks noGrp="1"/>
-          </p:cNvSpPr>
-          <p:nvPr>
-            <p:ph type="body" idx="3" sz="quarter"/>
-          </p:nvPr>
-        </p:nvSpPr>
-        <p:spPr/>
-        <p:txBody>
-          <a:bodyPr/>
-          <a:lstStyle/>
-          <a:p>
-            <a:r>
-              <a:t>We are Swaraj and Prajakta, team Dynamic Duo, committed to helping developers build products people actually want.</a:t>
-            </a:r>
-          </a:p>
-        </p:txBody>
-      </p:sp>
-      <p:sp>
-        <p:nvSpPr>
-          <p:cNvPr id="4" name="Slide Number Placeholder 3"/>
-          <p:cNvSpPr>
-            <a:spLocks noGrp="1"/>
-          </p:cNvSpPr>
-          <p:nvPr>
-            <p:ph type="sldNum" idx="5" sz="quarter"/>
-          </p:nvPr>
-        </p:nvSpPr>
-        <p:spPr/>
-      </p:sp>
-    </p:spTree>
-  </p:cSld>
-  <p:clrMapOvr>
-    <a:masterClrMapping/>
-  </p:clrMapOvr>
-</p:notes>
-</file>
-
 <file path=ppt/notesSlides/notesSlide2.xml><?xml version="1.0" encoding="utf-8"?>
 <p:notes xmlns:a="http://schemas.openxmlformats.org/drawingml/2006/main" xmlns:p="http://schemas.openxmlformats.org/presentationml/2006/main" xmlns:r="http://schemas.openxmlformats.org/officeDocument/2006/relationships">
   <p:cSld>
@@ -934,7 +649,7 @@
           <a:lstStyle/>
           <a:p>
             <a:r>
-              <a:t>Wasting 6 months building something nobody wants is the single biggest risk in startup creation. We solve this Day 1.</a:t>
+              <a:t>LaunchMind extracts assumptions, runs live web comparisons, and hands you an actionable roadmap in minutes.</a:t>
             </a:r>
           </a:p>
         </p:txBody>
@@ -1004,7 +719,7 @@
           <a:lstStyle/>
           <a:p>
             <a:r>
-              <a:t>LaunchMind extracts assumptions, runs live web comparisons, and hands you an actionable roadmap in minutes.</a:t>
+              <a:t>Our workflow guides the founder from raw ideation, to competitive defense, to a formatted execution plan.</a:t>
             </a:r>
           </a:p>
         </p:txBody>
@@ -1074,7 +789,7 @@
           <a:lstStyle/>
           <a:p>
             <a:r>
-              <a:t>Our workflow guides the founder from raw ideation, to competitive defense, to a formatted execution plan.</a:t>
+              <a:t>This is our key differentiator. Founders get grilled by simulated partners to test their market and tech defensibility.</a:t>
             </a:r>
           </a:p>
         </p:txBody>
@@ -1144,7 +859,7 @@
           <a:lstStyle/>
           <a:p>
             <a:r>
-              <a:t>This is our key differentiator. Founders get grilled by simulated partners to test their market and tech defensibility.</a:t>
+              <a:t>LaunchMind is faster, live-connected, and conversational — moving past static templates to interactive validation.</a:t>
             </a:r>
           </a:p>
         </p:txBody>
@@ -1214,7 +929,7 @@
           <a:lstStyle/>
           <a:p>
             <a:r>
-              <a:t>LaunchMind is faster, live-connected, and conversational — moving past static templates to interactive validation.</a:t>
+              <a:t>Our stateless backend scales horizontally, using asynchronous parallel requests to Gemini and search to keep response times low.</a:t>
             </a:r>
           </a:p>
         </p:txBody>
@@ -1284,77 +999,7 @@
           <a:lstStyle/>
           <a:p>
             <a:r>
-              <a:t>Our stateless backend scales horizontally, using asynchronous parallel requests to Gemini and search to keep response times low.</a:t>
-            </a:r>
-          </a:p>
-        </p:txBody>
-      </p:sp>
-      <p:sp>
-        <p:nvSpPr>
-          <p:cNvPr id="4" name="Slide Number Placeholder 3"/>
-          <p:cNvSpPr>
-            <a:spLocks noGrp="1"/>
-          </p:cNvSpPr>
-          <p:nvPr>
-            <p:ph type="sldNum" idx="5" sz="quarter"/>
-          </p:nvPr>
-        </p:nvSpPr>
-        <p:spPr/>
-      </p:sp>
-    </p:spTree>
-  </p:cSld>
-  <p:clrMapOvr>
-    <a:masterClrMapping/>
-  </p:clrMapOvr>
-</p:notes>
-</file>
-
-<file path=ppt/notesSlides/notesSlide9.xml><?xml version="1.0" encoding="utf-8"?>
-<p:notes xmlns:a="http://schemas.openxmlformats.org/drawingml/2006/main" xmlns:p="http://schemas.openxmlformats.org/presentationml/2006/main" xmlns:r="http://schemas.openxmlformats.org/officeDocument/2006/relationships">
-  <p:cSld>
-    <p:spTree>
-      <p:nvGrpSpPr>
-        <p:cNvPr id="1" name=""/>
-        <p:cNvGrpSpPr/>
-        <p:nvPr/>
-      </p:nvGrpSpPr>
-      <p:grpSpPr>
-        <a:xfrm>
-          <a:off x="0" y="0"/>
-          <a:ext cx="0" cy="0"/>
-          <a:chOff x="0" y="0"/>
-          <a:chExt cx="0" cy="0"/>
-        </a:xfrm>
-      </p:grpSpPr>
-      <p:sp>
-        <p:nvSpPr>
-          <p:cNvPr id="2" name="Slide Image Placeholder 1"/>
-          <p:cNvSpPr>
-            <a:spLocks noGrp="1"/>
-          </p:cNvSpPr>
-          <p:nvPr>
-            <p:ph type="sldImg" idx="2"/>
-          </p:nvPr>
-        </p:nvSpPr>
-        <p:spPr/>
-      </p:sp>
-      <p:sp>
-        <p:nvSpPr>
-          <p:cNvPr id="3" name="Notes Placeholder 2"/>
-          <p:cNvSpPr>
-            <a:spLocks noGrp="1"/>
-          </p:cNvSpPr>
-          <p:nvPr>
-            <p:ph type="body" idx="3" sz="quarter"/>
-          </p:nvPr>
-        </p:nvSpPr>
-        <p:spPr/>
-        <p:txBody>
-          <a:bodyPr/>
-          <a:lstStyle/>
-          <a:p>
-            <a:r>
-              <a:t>We have the core MVP ready. Next, we persist user sessions, add voice capability, and integrate historical YC benchmarking.</a:t>
+              <a:t>We are Swaraj and Prajakta, team Dynamic Duo, committed to helping developers build products people actually want.</a:t>
             </a:r>
           </a:p>
         </p:txBody>
@@ -4527,7 +4172,7 @@
               </a:defRPr>
             </a:pPr>
             <a:r>
-              <a:t>• Built by: Swaraj Kumar Behera &amp; Prajakta Kuila (Team: Dynamic Duo)</a:t>
+              <a:t>• Presenter: Swaraj Kumar Behera &amp; Prajakta Kuila (Team: Dynamic Duo)</a:t>
             </a:r>
           </a:p>
           <a:p>
@@ -4543,7 +4188,7 @@
               </a:defRPr>
             </a:pPr>
             <a:r>
-              <a:t>• For: InnovaHack Chapter 1 — Generative AI / Startup Innovation Track</a:t>
+              <a:t>• Track: Generative AI &amp; Startup Innovation Track</a:t>
             </a:r>
           </a:p>
           <a:p>
@@ -4559,895 +4204,7 @@
               </a:defRPr>
             </a:pPr>
             <a:r>
-              <a:t>• Web App URL: http://localhost:5173 / GitHub: swaraj3092/LaunchMind</a:t>
-            </a:r>
-          </a:p>
-        </p:txBody>
-      </p:sp>
-    </p:spTree>
-  </p:cSld>
-  <p:clrMapOvr>
-    <a:masterClrMapping/>
-  </p:clrMapOvr>
-</p:sld>
-</file>
-
-<file path=ppt/slides/slide10.xml><?xml version="1.0" encoding="utf-8"?>
-<p:sld xmlns:a="http://schemas.openxmlformats.org/drawingml/2006/main" xmlns:p="http://schemas.openxmlformats.org/presentationml/2006/main" xmlns:r="http://schemas.openxmlformats.org/officeDocument/2006/relationships">
-  <p:cSld>
-    <p:bg>
-      <p:bgPr>
-        <a:solidFill>
-          <a:srgbClr val="0C080D"/>
-        </a:solidFill>
-        <a:effectLst/>
-      </p:bgPr>
-    </p:bg>
-    <p:spTree>
-      <p:nvGrpSpPr>
-        <p:cNvPr id="1" name=""/>
-        <p:cNvGrpSpPr/>
-        <p:nvPr/>
-      </p:nvGrpSpPr>
-      <p:grpSpPr/>
-      <p:sp>
-        <p:nvSpPr>
-          <p:cNvPr id="2" name="TextBox 1"/>
-          <p:cNvSpPr txBox="1"/>
-          <p:nvPr/>
-        </p:nvSpPr>
-        <p:spPr>
-          <a:xfrm>
-            <a:off x="457200" y="365760"/>
-            <a:ext cx="1828800" cy="731520"/>
-          </a:xfrm>
-          <a:prstGeom prst="rect">
-            <a:avLst/>
-          </a:prstGeom>
-          <a:noFill/>
-        </p:spPr>
-        <p:txBody>
-          <a:bodyPr wrap="none">
-            <a:spAutoFit/>
-          </a:bodyPr>
-          <a:lstStyle/>
-          <a:p>
-            <a:pPr>
-              <a:defRPr sz="1400" b="1">
-                <a:solidFill>
-                  <a:srgbClr val="C084FC"/>
-                </a:solidFill>
-                <a:latin typeface="Courier New"/>
-              </a:defRPr>
-            </a:pPr>
-            <a:r>
-              <a:t>// SLIDE 10</a:t>
-            </a:r>
-          </a:p>
-        </p:txBody>
-      </p:sp>
-      <p:sp>
-        <p:nvSpPr>
-          <p:cNvPr id="3" name="TextBox 2"/>
-          <p:cNvSpPr txBox="1"/>
-          <p:nvPr/>
-        </p:nvSpPr>
-        <p:spPr>
-          <a:xfrm>
-            <a:off x="457200" y="731520"/>
-            <a:ext cx="10972800" cy="914400"/>
-          </a:xfrm>
-          <a:prstGeom prst="rect">
-            <a:avLst/>
-          </a:prstGeom>
-          <a:noFill/>
-        </p:spPr>
-        <p:txBody>
-          <a:bodyPr wrap="square">
-            <a:spAutoFit/>
-          </a:bodyPr>
-          <a:lstStyle/>
-          <a:p>
-            <a:pPr>
-              <a:defRPr sz="3600" b="1">
-                <a:solidFill>
-                  <a:srgbClr val="FF2D78"/>
-                </a:solidFill>
-                <a:latin typeface="Arial"/>
-              </a:defRPr>
-            </a:pPr>
-            <a:r>
-              <a:t>The Ask</a:t>
-            </a:r>
-          </a:p>
-        </p:txBody>
-      </p:sp>
-      <p:sp>
-        <p:nvSpPr>
-          <p:cNvPr id="4" name="TextBox 3"/>
-          <p:cNvSpPr txBox="1"/>
-          <p:nvPr/>
-        </p:nvSpPr>
-        <p:spPr>
-          <a:xfrm>
-            <a:off x="457200" y="1645920"/>
-            <a:ext cx="10972800" cy="457200"/>
-          </a:xfrm>
-          <a:prstGeom prst="rect">
-            <a:avLst/>
-          </a:prstGeom>
-          <a:noFill/>
-        </p:spPr>
-        <p:txBody>
-          <a:bodyPr wrap="square">
-            <a:spAutoFit/>
-          </a:bodyPr>
-          <a:lstStyle/>
-          <a:p>
-            <a:pPr>
-              <a:defRPr sz="1800" i="1">
-                <a:solidFill>
-                  <a:srgbClr val="C084FC"/>
-                </a:solidFill>
-                <a:latin typeface="Arial"/>
-              </a:defRPr>
-            </a:pPr>
-            <a:r>
-              <a:t>Partnering to scale startup validation.</a:t>
-            </a:r>
-          </a:p>
-        </p:txBody>
-      </p:sp>
-      <p:sp>
-        <p:nvSpPr>
-          <p:cNvPr id="5" name="TextBox 4"/>
-          <p:cNvSpPr txBox="1"/>
-          <p:nvPr/>
-        </p:nvSpPr>
-        <p:spPr>
-          <a:xfrm>
-            <a:off x="457200" y="2286000"/>
-            <a:ext cx="11274552" cy="3840480"/>
-          </a:xfrm>
-          <a:prstGeom prst="rect">
-            <a:avLst/>
-          </a:prstGeom>
-          <a:noFill/>
-        </p:spPr>
-        <p:txBody>
-          <a:bodyPr wrap="square">
-            <a:spAutoFit/>
-          </a:bodyPr>
-          <a:lstStyle/>
-          <a:p/>
-          <a:p>
-            <a:pPr>
-              <a:spcAft>
-                <a:spcPts val="1400"/>
-              </a:spcAft>
-              <a:defRPr sz="1600">
-                <a:solidFill>
-                  <a:srgbClr val="FFF0F5"/>
-                </a:solidFill>
-                <a:latin typeface="Arial"/>
-              </a:defRPr>
-            </a:pPr>
-            <a:r>
-              <a:t>• Stage: Working prototype deployed and open-source on GitHub.</a:t>
-            </a:r>
-          </a:p>
-          <a:p>
-            <a:pPr>
-              <a:spcAft>
-                <a:spcPts val="1400"/>
-              </a:spcAft>
-              <a:defRPr sz="1600">
-                <a:solidFill>
-                  <a:srgbClr val="FFF0F5"/>
-                </a:solidFill>
-                <a:latin typeface="Arial"/>
-              </a:defRPr>
-            </a:pPr>
-            <a:r>
-              <a:t>• Incubator Partnerships: License to university networks, venture studios, and incubators.</a:t>
-            </a:r>
-          </a:p>
-          <a:p>
-            <a:pPr>
-              <a:spcAft>
-                <a:spcPts val="1400"/>
-              </a:spcAft>
-              <a:defRPr sz="1600">
-                <a:solidFill>
-                  <a:srgbClr val="FFF0F5"/>
-                </a:solidFill>
-                <a:latin typeface="Arial"/>
-              </a:defRPr>
-            </a:pPr>
-            <a:r>
-              <a:t>• Hackathon Integrations: Position LaunchMind as the official pre-validation tool for hackathons.</a:t>
-            </a:r>
-          </a:p>
-          <a:p>
-            <a:pPr>
-              <a:spcAft>
-                <a:spcPts val="1400"/>
-              </a:spcAft>
-              <a:defRPr sz="1600">
-                <a:solidFill>
-                  <a:srgbClr val="FFF0F5"/>
-                </a:solidFill>
-                <a:latin typeface="Arial"/>
-              </a:defRPr>
-            </a:pPr>
-            <a:r>
-              <a:t>• Vision: To become the global standard for pre-seed project validation.</a:t>
-            </a:r>
-          </a:p>
-        </p:txBody>
-      </p:sp>
-    </p:spTree>
-  </p:cSld>
-  <p:clrMapOvr>
-    <a:masterClrMapping/>
-  </p:clrMapOvr>
-</p:sld>
-</file>
-
-<file path=ppt/slides/slide11.xml><?xml version="1.0" encoding="utf-8"?>
-<p:sld xmlns:a="http://schemas.openxmlformats.org/drawingml/2006/main" xmlns:p="http://schemas.openxmlformats.org/presentationml/2006/main" xmlns:r="http://schemas.openxmlformats.org/officeDocument/2006/relationships">
-  <p:cSld>
-    <p:bg>
-      <p:bgPr>
-        <a:solidFill>
-          <a:srgbClr val="0C080D"/>
-        </a:solidFill>
-        <a:effectLst/>
-      </p:bgPr>
-    </p:bg>
-    <p:spTree>
-      <p:nvGrpSpPr>
-        <p:cNvPr id="1" name=""/>
-        <p:cNvGrpSpPr/>
-        <p:nvPr/>
-      </p:nvGrpSpPr>
-      <p:grpSpPr/>
-      <p:sp>
-        <p:nvSpPr>
-          <p:cNvPr id="2" name="TextBox 1"/>
-          <p:cNvSpPr txBox="1"/>
-          <p:nvPr/>
-        </p:nvSpPr>
-        <p:spPr>
-          <a:xfrm>
-            <a:off x="457200" y="365760"/>
-            <a:ext cx="1828800" cy="731520"/>
-          </a:xfrm>
-          <a:prstGeom prst="rect">
-            <a:avLst/>
-          </a:prstGeom>
-          <a:noFill/>
-        </p:spPr>
-        <p:txBody>
-          <a:bodyPr wrap="none">
-            <a:spAutoFit/>
-          </a:bodyPr>
-          <a:lstStyle/>
-          <a:p>
-            <a:pPr>
-              <a:defRPr sz="1400" b="1">
-                <a:solidFill>
-                  <a:srgbClr val="C084FC"/>
-                </a:solidFill>
-                <a:latin typeface="Courier New"/>
-              </a:defRPr>
-            </a:pPr>
-            <a:r>
-              <a:t>// SLIDE 11</a:t>
-            </a:r>
-          </a:p>
-        </p:txBody>
-      </p:sp>
-      <p:sp>
-        <p:nvSpPr>
-          <p:cNvPr id="3" name="TextBox 2"/>
-          <p:cNvSpPr txBox="1"/>
-          <p:nvPr/>
-        </p:nvSpPr>
-        <p:spPr>
-          <a:xfrm>
-            <a:off x="457200" y="731520"/>
-            <a:ext cx="10972800" cy="914400"/>
-          </a:xfrm>
-          <a:prstGeom prst="rect">
-            <a:avLst/>
-          </a:prstGeom>
-          <a:noFill/>
-        </p:spPr>
-        <p:txBody>
-          <a:bodyPr wrap="square">
-            <a:spAutoFit/>
-          </a:bodyPr>
-          <a:lstStyle/>
-          <a:p>
-            <a:pPr>
-              <a:defRPr sz="3600" b="1">
-                <a:solidFill>
-                  <a:srgbClr val="FF2D78"/>
-                </a:solidFill>
-                <a:latin typeface="Arial"/>
-              </a:defRPr>
-            </a:pPr>
-            <a:r>
-              <a:t>Business Model</a:t>
-            </a:r>
-          </a:p>
-        </p:txBody>
-      </p:sp>
-      <p:sp>
-        <p:nvSpPr>
-          <p:cNvPr id="4" name="TextBox 3"/>
-          <p:cNvSpPr txBox="1"/>
-          <p:nvPr/>
-        </p:nvSpPr>
-        <p:spPr>
-          <a:xfrm>
-            <a:off x="457200" y="1645920"/>
-            <a:ext cx="10972800" cy="457200"/>
-          </a:xfrm>
-          <a:prstGeom prst="rect">
-            <a:avLst/>
-          </a:prstGeom>
-          <a:noFill/>
-        </p:spPr>
-        <p:txBody>
-          <a:bodyPr wrap="square">
-            <a:spAutoFit/>
-          </a:bodyPr>
-          <a:lstStyle/>
-          <a:p>
-            <a:pPr>
-              <a:defRPr sz="1800" i="1">
-                <a:solidFill>
-                  <a:srgbClr val="C084FC"/>
-                </a:solidFill>
-                <a:latin typeface="Arial"/>
-              </a:defRPr>
-            </a:pPr>
-            <a:r>
-              <a:t>Scalable SaaS monetization strategy.</a:t>
-            </a:r>
-          </a:p>
-        </p:txBody>
-      </p:sp>
-      <p:sp>
-        <p:nvSpPr>
-          <p:cNvPr id="5" name="TextBox 4"/>
-          <p:cNvSpPr txBox="1"/>
-          <p:nvPr/>
-        </p:nvSpPr>
-        <p:spPr>
-          <a:xfrm>
-            <a:off x="457200" y="2286000"/>
-            <a:ext cx="11274552" cy="3840480"/>
-          </a:xfrm>
-          <a:prstGeom prst="rect">
-            <a:avLst/>
-          </a:prstGeom>
-          <a:noFill/>
-        </p:spPr>
-        <p:txBody>
-          <a:bodyPr wrap="square">
-            <a:spAutoFit/>
-          </a:bodyPr>
-          <a:lstStyle/>
-          <a:p/>
-          <a:p>
-            <a:pPr>
-              <a:spcAft>
-                <a:spcPts val="1400"/>
-              </a:spcAft>
-              <a:defRPr sz="1600">
-                <a:solidFill>
-                  <a:srgbClr val="FFF0F5"/>
-                </a:solidFill>
-                <a:latin typeface="Arial"/>
-              </a:defRPr>
-            </a:pPr>
-            <a:r>
-              <a:t>• Freemium Tier: 3 free startup idea validations per month for individual developers.</a:t>
-            </a:r>
-          </a:p>
-          <a:p>
-            <a:pPr>
-              <a:spcAft>
-                <a:spcPts val="1400"/>
-              </a:spcAft>
-              <a:defRPr sz="1600">
-                <a:solidFill>
-                  <a:srgbClr val="FFF0F5"/>
-                </a:solidFill>
-                <a:latin typeface="Arial"/>
-              </a:defRPr>
-            </a:pPr>
-            <a:r>
-              <a:t>• Pro Subscription ($19/mo): Unlimited idea tests, full VC Room access, and advanced PDF exports.</a:t>
-            </a:r>
-          </a:p>
-          <a:p>
-            <a:pPr>
-              <a:spcAft>
-                <a:spcPts val="1400"/>
-              </a:spcAft>
-              <a:defRPr sz="1600">
-                <a:solidFill>
-                  <a:srgbClr val="FFF0F5"/>
-                </a:solidFill>
-                <a:latin typeface="Arial"/>
-              </a:defRPr>
-            </a:pPr>
-            <a:r>
-              <a:t>• Enterprise Licensing: Dedicated validation dashboards for university hubs and accelerators.</a:t>
-            </a:r>
-          </a:p>
-          <a:p>
-            <a:pPr>
-              <a:spcAft>
-                <a:spcPts val="1400"/>
-              </a:spcAft>
-              <a:defRPr sz="1600">
-                <a:solidFill>
-                  <a:srgbClr val="FFF0F5"/>
-                </a:solidFill>
-                <a:latin typeface="Arial"/>
-              </a:defRPr>
-            </a:pPr>
-            <a:r>
-              <a:t>• API License: Licensing validation APIs to developer platforms and startup application portals.</a:t>
-            </a:r>
-          </a:p>
-        </p:txBody>
-      </p:sp>
-    </p:spTree>
-  </p:cSld>
-  <p:clrMapOvr>
-    <a:masterClrMapping/>
-  </p:clrMapOvr>
-</p:sld>
-</file>
-
-<file path=ppt/slides/slide12.xml><?xml version="1.0" encoding="utf-8"?>
-<p:sld xmlns:a="http://schemas.openxmlformats.org/drawingml/2006/main" xmlns:p="http://schemas.openxmlformats.org/presentationml/2006/main" xmlns:r="http://schemas.openxmlformats.org/officeDocument/2006/relationships">
-  <p:cSld>
-    <p:bg>
-      <p:bgPr>
-        <a:solidFill>
-          <a:srgbClr val="0C080D"/>
-        </a:solidFill>
-        <a:effectLst/>
-      </p:bgPr>
-    </p:bg>
-    <p:spTree>
-      <p:nvGrpSpPr>
-        <p:cNvPr id="1" name=""/>
-        <p:cNvGrpSpPr/>
-        <p:nvPr/>
-      </p:nvGrpSpPr>
-      <p:grpSpPr/>
-      <p:sp>
-        <p:nvSpPr>
-          <p:cNvPr id="2" name="TextBox 1"/>
-          <p:cNvSpPr txBox="1"/>
-          <p:nvPr/>
-        </p:nvSpPr>
-        <p:spPr>
-          <a:xfrm>
-            <a:off x="457200" y="365760"/>
-            <a:ext cx="1828800" cy="731520"/>
-          </a:xfrm>
-          <a:prstGeom prst="rect">
-            <a:avLst/>
-          </a:prstGeom>
-          <a:noFill/>
-        </p:spPr>
-        <p:txBody>
-          <a:bodyPr wrap="none">
-            <a:spAutoFit/>
-          </a:bodyPr>
-          <a:lstStyle/>
-          <a:p>
-            <a:pPr>
-              <a:defRPr sz="1400" b="1">
-                <a:solidFill>
-                  <a:srgbClr val="C084FC"/>
-                </a:solidFill>
-                <a:latin typeface="Courier New"/>
-              </a:defRPr>
-            </a:pPr>
-            <a:r>
-              <a:t>// SLIDE 12</a:t>
-            </a:r>
-          </a:p>
-        </p:txBody>
-      </p:sp>
-      <p:sp>
-        <p:nvSpPr>
-          <p:cNvPr id="3" name="TextBox 2"/>
-          <p:cNvSpPr txBox="1"/>
-          <p:nvPr/>
-        </p:nvSpPr>
-        <p:spPr>
-          <a:xfrm>
-            <a:off x="457200" y="731520"/>
-            <a:ext cx="10972800" cy="914400"/>
-          </a:xfrm>
-          <a:prstGeom prst="rect">
-            <a:avLst/>
-          </a:prstGeom>
-          <a:noFill/>
-        </p:spPr>
-        <p:txBody>
-          <a:bodyPr wrap="square">
-            <a:spAutoFit/>
-          </a:bodyPr>
-          <a:lstStyle/>
-          <a:p>
-            <a:pPr>
-              <a:defRPr sz="3600" b="1">
-                <a:solidFill>
-                  <a:srgbClr val="FF2D78"/>
-                </a:solidFill>
-                <a:latin typeface="Arial"/>
-              </a:defRPr>
-            </a:pPr>
-            <a:r>
-              <a:t>Go-To-Market</a:t>
-            </a:r>
-          </a:p>
-        </p:txBody>
-      </p:sp>
-      <p:sp>
-        <p:nvSpPr>
-          <p:cNvPr id="4" name="TextBox 3"/>
-          <p:cNvSpPr txBox="1"/>
-          <p:nvPr/>
-        </p:nvSpPr>
-        <p:spPr>
-          <a:xfrm>
-            <a:off x="457200" y="1645920"/>
-            <a:ext cx="10972800" cy="457200"/>
-          </a:xfrm>
-          <a:prstGeom prst="rect">
-            <a:avLst/>
-          </a:prstGeom>
-          <a:noFill/>
-        </p:spPr>
-        <p:txBody>
-          <a:bodyPr wrap="square">
-            <a:spAutoFit/>
-          </a:bodyPr>
-          <a:lstStyle/>
-          <a:p>
-            <a:pPr>
-              <a:defRPr sz="1800" i="1">
-                <a:solidFill>
-                  <a:srgbClr val="C084FC"/>
-                </a:solidFill>
-                <a:latin typeface="Arial"/>
-              </a:defRPr>
-            </a:pPr>
-            <a:r>
-              <a:t>Reaching builders at the source.</a:t>
-            </a:r>
-          </a:p>
-        </p:txBody>
-      </p:sp>
-      <p:sp>
-        <p:nvSpPr>
-          <p:cNvPr id="5" name="TextBox 4"/>
-          <p:cNvSpPr txBox="1"/>
-          <p:nvPr/>
-        </p:nvSpPr>
-        <p:spPr>
-          <a:xfrm>
-            <a:off x="457200" y="2286000"/>
-            <a:ext cx="11274552" cy="3840480"/>
-          </a:xfrm>
-          <a:prstGeom prst="rect">
-            <a:avLst/>
-          </a:prstGeom>
-          <a:noFill/>
-        </p:spPr>
-        <p:txBody>
-          <a:bodyPr wrap="square">
-            <a:spAutoFit/>
-          </a:bodyPr>
-          <a:lstStyle/>
-          <a:p/>
-          <a:p>
-            <a:pPr>
-              <a:spcAft>
-                <a:spcPts val="1400"/>
-              </a:spcAft>
-              <a:defRPr sz="1600">
-                <a:solidFill>
-                  <a:srgbClr val="FFF0F5"/>
-                </a:solidFill>
-                <a:latin typeface="Arial"/>
-              </a:defRPr>
-            </a:pPr>
-            <a:r>
-              <a:t>• Hackathon Partnerships: Standardize LaunchMind as the pre-submission check for hackathons.</a:t>
-            </a:r>
-          </a:p>
-          <a:p>
-            <a:pPr>
-              <a:spcAft>
-                <a:spcPts val="1400"/>
-              </a:spcAft>
-              <a:defRPr sz="1600">
-                <a:solidFill>
-                  <a:srgbClr val="FFF0F5"/>
-                </a:solidFill>
-                <a:latin typeface="Arial"/>
-              </a:defRPr>
-            </a:pPr>
-            <a:r>
-              <a:t>• GitHub Action: Trigger a validation audit on repository creation via GitHub marketplace.</a:t>
-            </a:r>
-          </a:p>
-          <a:p>
-            <a:pPr>
-              <a:spcAft>
-                <a:spcPts val="1400"/>
-              </a:spcAft>
-              <a:defRPr sz="1600">
-                <a:solidFill>
-                  <a:srgbClr val="FFF0F5"/>
-                </a:solidFill>
-                <a:latin typeface="Arial"/>
-              </a:defRPr>
-            </a:pPr>
-            <a:r>
-              <a:t>• Build In Public: Drive organic traffic via viral LinkedIn and Twitter posts showing VC roasts.</a:t>
-            </a:r>
-          </a:p>
-          <a:p>
-            <a:pPr>
-              <a:spcAft>
-                <a:spcPts val="1400"/>
-              </a:spcAft>
-              <a:defRPr sz="1600">
-                <a:solidFill>
-                  <a:srgbClr val="FFF0F5"/>
-                </a:solidFill>
-                <a:latin typeface="Arial"/>
-              </a:defRPr>
-            </a:pPr>
-            <a:r>
-              <a:t>• Startup Hub Onboarding: Partner with incubator networks to use LaunchMind for cohort screening.</a:t>
-            </a:r>
-          </a:p>
-        </p:txBody>
-      </p:sp>
-    </p:spTree>
-  </p:cSld>
-  <p:clrMapOvr>
-    <a:masterClrMapping/>
-  </p:clrMapOvr>
-</p:sld>
-</file>
-
-<file path=ppt/slides/slide13.xml><?xml version="1.0" encoding="utf-8"?>
-<p:sld xmlns:a="http://schemas.openxmlformats.org/drawingml/2006/main" xmlns:p="http://schemas.openxmlformats.org/presentationml/2006/main" xmlns:r="http://schemas.openxmlformats.org/officeDocument/2006/relationships">
-  <p:cSld>
-    <p:bg>
-      <p:bgPr>
-        <a:solidFill>
-          <a:srgbClr val="0C080D"/>
-        </a:solidFill>
-        <a:effectLst/>
-      </p:bgPr>
-    </p:bg>
-    <p:spTree>
-      <p:nvGrpSpPr>
-        <p:cNvPr id="1" name=""/>
-        <p:cNvGrpSpPr/>
-        <p:nvPr/>
-      </p:nvGrpSpPr>
-      <p:grpSpPr/>
-      <p:sp>
-        <p:nvSpPr>
-          <p:cNvPr id="2" name="TextBox 1"/>
-          <p:cNvSpPr txBox="1"/>
-          <p:nvPr/>
-        </p:nvSpPr>
-        <p:spPr>
-          <a:xfrm>
-            <a:off x="457200" y="365760"/>
-            <a:ext cx="1828800" cy="731520"/>
-          </a:xfrm>
-          <a:prstGeom prst="rect">
-            <a:avLst/>
-          </a:prstGeom>
-          <a:noFill/>
-        </p:spPr>
-        <p:txBody>
-          <a:bodyPr wrap="none">
-            <a:spAutoFit/>
-          </a:bodyPr>
-          <a:lstStyle/>
-          <a:p>
-            <a:pPr>
-              <a:defRPr sz="1400" b="1">
-                <a:solidFill>
-                  <a:srgbClr val="C084FC"/>
-                </a:solidFill>
-                <a:latin typeface="Courier New"/>
-              </a:defRPr>
-            </a:pPr>
-            <a:r>
-              <a:t>// SLIDE 13</a:t>
-            </a:r>
-          </a:p>
-        </p:txBody>
-      </p:sp>
-      <p:sp>
-        <p:nvSpPr>
-          <p:cNvPr id="3" name="TextBox 2"/>
-          <p:cNvSpPr txBox="1"/>
-          <p:nvPr/>
-        </p:nvSpPr>
-        <p:spPr>
-          <a:xfrm>
-            <a:off x="457200" y="731520"/>
-            <a:ext cx="10972800" cy="914400"/>
-          </a:xfrm>
-          <a:prstGeom prst="rect">
-            <a:avLst/>
-          </a:prstGeom>
-          <a:noFill/>
-        </p:spPr>
-        <p:txBody>
-          <a:bodyPr wrap="square">
-            <a:spAutoFit/>
-          </a:bodyPr>
-          <a:lstStyle/>
-          <a:p>
-            <a:pPr>
-              <a:defRPr sz="3600" b="1">
-                <a:solidFill>
-                  <a:srgbClr val="FF2D78"/>
-                </a:solidFill>
-                <a:latin typeface="Arial"/>
-              </a:defRPr>
-            </a:pPr>
-            <a:r>
-              <a:t>The Team</a:t>
-            </a:r>
-          </a:p>
-        </p:txBody>
-      </p:sp>
-      <p:sp>
-        <p:nvSpPr>
-          <p:cNvPr id="4" name="TextBox 3"/>
-          <p:cNvSpPr txBox="1"/>
-          <p:nvPr/>
-        </p:nvSpPr>
-        <p:spPr>
-          <a:xfrm>
-            <a:off x="457200" y="1645920"/>
-            <a:ext cx="10972800" cy="457200"/>
-          </a:xfrm>
-          <a:prstGeom prst="rect">
-            <a:avLst/>
-          </a:prstGeom>
-          <a:noFill/>
-        </p:spPr>
-        <p:txBody>
-          <a:bodyPr wrap="square">
-            <a:spAutoFit/>
-          </a:bodyPr>
-          <a:lstStyle/>
-          <a:p>
-            <a:pPr>
-              <a:defRPr sz="1800" i="1">
-                <a:solidFill>
-                  <a:srgbClr val="C084FC"/>
-                </a:solidFill>
-                <a:latin typeface="Arial"/>
-              </a:defRPr>
-            </a:pPr>
-            <a:r>
-              <a:t>Team Dynamic Duo — Curing the Builder's Blindspot.</a:t>
-            </a:r>
-          </a:p>
-        </p:txBody>
-      </p:sp>
-      <p:sp>
-        <p:nvSpPr>
-          <p:cNvPr id="5" name="TextBox 4"/>
-          <p:cNvSpPr txBox="1"/>
-          <p:nvPr/>
-        </p:nvSpPr>
-        <p:spPr>
-          <a:xfrm>
-            <a:off x="457200" y="2286000"/>
-            <a:ext cx="11274552" cy="3840480"/>
-          </a:xfrm>
-          <a:prstGeom prst="rect">
-            <a:avLst/>
-          </a:prstGeom>
-          <a:noFill/>
-        </p:spPr>
-        <p:txBody>
-          <a:bodyPr wrap="square">
-            <a:spAutoFit/>
-          </a:bodyPr>
-          <a:lstStyle/>
-          <a:p/>
-          <a:p>
-            <a:pPr>
-              <a:spcAft>
-                <a:spcPts val="1400"/>
-              </a:spcAft>
-              <a:defRPr sz="1600">
-                <a:solidFill>
-                  <a:srgbClr val="FFF0F5"/>
-                </a:solidFill>
-                <a:latin typeface="Arial"/>
-              </a:defRPr>
-            </a:pPr>
-            <a:r>
-              <a:t>• Swaraj Kumar Behera — Fullstack Developer &amp; AI Integration Specialist.</a:t>
-            </a:r>
-          </a:p>
-          <a:p>
-            <a:pPr>
-              <a:spcAft>
-                <a:spcPts val="1400"/>
-              </a:spcAft>
-              <a:defRPr sz="1600">
-                <a:solidFill>
-                  <a:srgbClr val="FFF0F5"/>
-                </a:solidFill>
-                <a:latin typeface="Arial"/>
-              </a:defRPr>
-            </a:pPr>
-            <a:r>
-              <a:t>• Prajakta Kuila — Frontend Engineer &amp; Lead UI/UX Designer.</a:t>
-            </a:r>
-          </a:p>
-          <a:p>
-            <a:pPr>
-              <a:spcAft>
-                <a:spcPts val="1400"/>
-              </a:spcAft>
-              <a:defRPr sz="1600">
-                <a:solidFill>
-                  <a:srgbClr val="FFF0F5"/>
-                </a:solidFill>
-                <a:latin typeface="Arial"/>
-              </a:defRPr>
-            </a:pPr>
-            <a:r>
-              <a:t>• Our Goal: Making startup validation accessible, fast, and objective.</a:t>
-            </a:r>
-          </a:p>
-          <a:p>
-            <a:pPr>
-              <a:spcAft>
-                <a:spcPts val="1400"/>
-              </a:spcAft>
-              <a:defRPr sz="1600">
-                <a:solidFill>
-                  <a:srgbClr val="FFF0F5"/>
-                </a:solidFill>
-                <a:latin typeface="Arial"/>
-              </a:defRPr>
-            </a:pPr>
-            <a:r>
-              <a:t>• GitHub Repo: https://github.com/swaraj3092/LaunchMind</a:t>
+              <a:t>• GitHub Repository: https://github.com/swaraj3092/LaunchMind</a:t>
             </a:r>
           </a:p>
         </p:txBody>
@@ -5621,7 +4378,7 @@
               </a:defRPr>
             </a:pPr>
             <a:r>
-              <a:t>• Echo Chambers: Founders validate ideas with supportive friends instead of market realities.</a:t>
+              <a:t>• The Builder's Blindspot: spending 6 months coding before spending 6 minutes validating.</a:t>
             </a:r>
           </a:p>
           <a:p>
@@ -5637,7 +4394,7 @@
               </a:defRPr>
             </a:pPr>
             <a:r>
-              <a:t>• Premature Optimization: Jumping straight into code before validating customer pain points.</a:t>
+              <a:t>• CB Insights: 'No Market Need' is the #1 cause of startup post-mortems (35%).</a:t>
             </a:r>
           </a:p>
           <a:p>
@@ -5653,7 +4410,7 @@
               </a:defRPr>
             </a:pPr>
             <a:r>
-              <a:t>• Consultancy Barrier: Getting expert startup advice or VC feedback is expensive and out of reach.</a:t>
+              <a:t>• Founders rely on supportive friends instead of objective market feedback.</a:t>
             </a:r>
           </a:p>
           <a:p>
@@ -5669,7 +4426,7 @@
               </a:defRPr>
             </a:pPr>
             <a:r>
-              <a:t>• Resource Loss: Billions of dollars and millions of hours of builder potential wasted annually.</a:t>
+              <a:t>• Expert startup advice and partner-level feedback is expensive and out of reach.</a:t>
             </a:r>
           </a:p>
         </p:txBody>
@@ -5767,7 +4524,7 @@
               </a:defRPr>
             </a:pPr>
             <a:r>
-              <a:t>The Builder's Blindspot</a:t>
+              <a:t>The Solution</a:t>
             </a:r>
           </a:p>
         </p:txBody>
@@ -5803,7 +4560,7 @@
               </a:defRPr>
             </a:pPr>
             <a:r>
-              <a:t>35% of startups fail because of 'No Market Need'.</a:t>
+              <a:t>An always-on AI co-founder that stress-tests your idea.</a:t>
             </a:r>
           </a:p>
         </p:txBody>
@@ -5843,7 +4600,7 @@
               </a:defRPr>
             </a:pPr>
             <a:r>
-              <a:t>• Over 90% of tech startups fail within the first 3 years.</a:t>
+              <a:t>• Idea Interrogation: A personalized 5-question PM validation engine (Roast Mode 🔥).</a:t>
             </a:r>
           </a:p>
           <a:p>
@@ -5859,7 +4616,7 @@
               </a:defRPr>
             </a:pPr>
             <a:r>
-              <a:t>• CB Insights flags 'No Market Need' as the #1 cause of startup post-mortems (35%).</a:t>
+              <a:t>• Live Web Intel: Real-time search scraping to find active, live competitors.</a:t>
             </a:r>
           </a:p>
           <a:p>
@@ -5875,7 +4632,7 @@
               </a:defRPr>
             </a:pPr>
             <a:r>
-              <a:t>• Builders spend 6 months writing code before spending 6 minutes validating market realities.</a:t>
+              <a:t>• Assumption Kill-Check: Surfaces the top 3 unvalidated risks that could kill the startup.</a:t>
             </a:r>
           </a:p>
           <a:p>
@@ -5891,7 +4648,7 @@
               </a:defRPr>
             </a:pPr>
             <a:r>
-              <a:t>• LaunchMind exists to bridge the gap between initial ideation and actual market validation.</a:t>
+              <a:t>• Action Roadmap: A structured 30/60/90-day plan with an actionable Day 1 checklist.</a:t>
             </a:r>
           </a:p>
         </p:txBody>
@@ -5989,7 +4746,7 @@
               </a:defRPr>
             </a:pPr>
             <a:r>
-              <a:t>Our Solution</a:t>
+              <a:t>How It Works</a:t>
             </a:r>
           </a:p>
         </p:txBody>
@@ -6025,7 +4782,7 @@
               </a:defRPr>
             </a:pPr>
             <a:r>
-              <a:t>An always-on AI co-founder and Silicon Valley VC.</a:t>
+              <a:t>The 4-step validation funnel.</a:t>
             </a:r>
           </a:p>
         </p:txBody>
@@ -6065,7 +4822,7 @@
               </a:defRPr>
             </a:pPr>
             <a:r>
-              <a:t>• Idea Interrogation: A personalized 5-question engine that grills the founder's assumptions.</a:t>
+              <a:t>• 1. Raw Idea Input: The founder describes their vision in one simple sentence.</a:t>
             </a:r>
           </a:p>
           <a:p>
@@ -6081,7 +4838,7 @@
               </a:defRPr>
             </a:pPr>
             <a:r>
-              <a:t>• Live Web Intel: Real-time search scraping to find active, live competitors.</a:t>
+              <a:t>• 2. AI Interrogation: Answer 5 targeted questions (Normal or Roast Mode 🔥).</a:t>
             </a:r>
           </a:p>
           <a:p>
@@ -6097,7 +4854,7 @@
               </a:defRPr>
             </a:pPr>
             <a:r>
-              <a:t>• Assumption Kill-Check: Surfaces the top 3 unvalidated risks that could kill the startup.</a:t>
+              <a:t>• 3. Plan Synthesis: AI creates roadmap, lists competitors, and calculates market size.</a:t>
             </a:r>
           </a:p>
           <a:p>
@@ -6113,7 +4870,7 @@
               </a:defRPr>
             </a:pPr>
             <a:r>
-              <a:t>• Action Roadmap: A structured 30/60/90-day plan with an actionable Day 1 checklist.</a:t>
+              <a:t>• 4. Live VC Pitch: Defend the idea in the Pitch Room and get a Venture Readiness Score.</a:t>
             </a:r>
           </a:p>
         </p:txBody>
@@ -6211,7 +4968,7 @@
               </a:defRPr>
             </a:pPr>
             <a:r>
-              <a:t>How It Works</a:t>
+              <a:t>Key Differentiator: VC Pitch Room</a:t>
             </a:r>
           </a:p>
         </p:txBody>
@@ -6247,7 +5004,7 @@
               </a:defRPr>
             </a:pPr>
             <a:r>
-              <a:t>The 4-step validation funnel.</a:t>
+              <a:t>Interactive VC pitch room with real-time score tracking.</a:t>
             </a:r>
           </a:p>
         </p:txBody>
@@ -6287,7 +5044,7 @@
               </a:defRPr>
             </a:pPr>
             <a:r>
-              <a:t>• 1. Raw Idea Input: The founder describes their vision in one simple sentence.</a:t>
+              <a:t>• 3 AI Personas: Marcus Vance (Skeptic), Elena Rostova (Growth), Dr. Aris Thorne (Deep Tech).</a:t>
             </a:r>
           </a:p>
           <a:p>
@@ -6303,7 +5060,7 @@
               </a:defRPr>
             </a:pPr>
             <a:r>
-              <a:t>• 2. AI Interrogation: Answer 5 targeted questions (Normal or Roast Mode 🔥).</a:t>
+              <a:t>• Real-time Scoring: Real-time scoreboard updates (+8 Strong, -4 Weak) based on user answers.</a:t>
             </a:r>
           </a:p>
           <a:p>
@@ -6319,7 +5076,7 @@
               </a:defRPr>
             </a:pPr>
             <a:r>
-              <a:t>• 3. Plan Synthesis: AI creates roadmap, lists competitors, and calculates market size.</a:t>
+              <a:t>• AI-driven Due Diligence: 4 rounds of sharp, semantic follow-up questions.</a:t>
             </a:r>
           </a:p>
           <a:p>
@@ -6335,7 +5092,7 @@
               </a:defRPr>
             </a:pPr>
             <a:r>
-              <a:t>• 4. Live VC Pitch: Defend the idea in the Pitch Room and get a Venture Readiness Score.</a:t>
+              <a:t>• Partner Verdict: Full capital decision (Invest/Pass) with feedback logging.</a:t>
             </a:r>
           </a:p>
         </p:txBody>
@@ -6433,7 +5190,7 @@
               </a:defRPr>
             </a:pPr>
             <a:r>
-              <a:t>The VC Pitch Room</a:t>
+              <a:t>Market Size &amp; Competition</a:t>
             </a:r>
           </a:p>
         </p:txBody>
@@ -6469,7 +5226,7 @@
               </a:defRPr>
             </a:pPr>
             <a:r>
-              <a:t>Interactive VC pitch room with real-time score tracking.</a:t>
+              <a:t>Validating the opportunity.</a:t>
             </a:r>
           </a:p>
         </p:txBody>
@@ -6509,7 +5266,7 @@
               </a:defRPr>
             </a:pPr>
             <a:r>
-              <a:t>• 3 AI Personas: Marcus Vance (Skeptic), Elena Rostova (Growth), Dr. Aris Thorne (Deep Tech).</a:t>
+              <a:t>• TAM/SAM/SOM Sizing: Interactive charts show Dollar Value market benchmarks.</a:t>
             </a:r>
           </a:p>
           <a:p>
@@ -6525,7 +5282,7 @@
               </a:defRPr>
             </a:pPr>
             <a:r>
-              <a:t>• Real-time Scoring: Real-time scoreboard updates (e.g. +10 Strong, -5 Red Flag) after each response.</a:t>
+              <a:t>• Competitor Scraper: Real-time DuckDuckGo searches fetch competitor links &amp; descriptions.</a:t>
             </a:r>
           </a:p>
           <a:p>
@@ -6541,7 +5298,7 @@
               </a:defRPr>
             </a:pPr>
             <a:r>
-              <a:t>• AI-driven Due Diligence: 4 rounds of sharp, semantic follow-up questions tailored to your inputs.</a:t>
+              <a:t>• benchmarking: Visually benchmarks your idea scores against competitor metrics.</a:t>
             </a:r>
           </a:p>
           <a:p>
@@ -6557,7 +5314,7 @@
               </a:defRPr>
             </a:pPr>
             <a:r>
-              <a:t>• Final Verdict: A blunt partner-level decision (Invest/Pass) with a complete feedback log.</a:t>
+              <a:t>• Differentiator Map: Pre-formats differentiators against Wave, FreshBooks, and Contra.</a:t>
             </a:r>
           </a:p>
         </p:txBody>
@@ -6655,7 +5412,7 @@
               </a:defRPr>
             </a:pPr>
             <a:r>
-              <a:t>Competitive Advantage</a:t>
+              <a:t>Tech Stack &amp; Roadmap</a:t>
             </a:r>
           </a:p>
         </p:txBody>
@@ -6691,7 +5448,7 @@
               </a:defRPr>
             </a:pPr>
             <a:r>
-              <a:t>LaunchMind vs. Traditional Alternatives.</a:t>
+              <a:t>Built for speed, safety, and scale.</a:t>
             </a:r>
           </a:p>
         </p:txBody>
@@ -6731,7 +5488,7 @@
               </a:defRPr>
             </a:pPr>
             <a:r>
-              <a:t>• Real-Time Scraping: Unlike database tools, we run live search queries to catch active competitors.</a:t>
+              <a:t>• Frontend: React SPA using Vite, TypeScript, TailwindCSS, and Framer Motion.</a:t>
             </a:r>
           </a:p>
           <a:p>
@@ -6747,7 +5504,7 @@
               </a:defRPr>
             </a:pPr>
             <a:r>
-              <a:t>• Interactive VC: Moving past static plans to an active, conversational partner simulator.</a:t>
+              <a:t>• Backend: FastAPI (Python) asynchronous REST API endpoints.</a:t>
             </a:r>
           </a:p>
           <a:p>
@@ -6763,7 +5520,7 @@
               </a:defRPr>
             </a:pPr>
             <a:r>
-              <a:t>• Frictionless UX: Fast, glassmorphic React SPA designed for modern developers.</a:t>
+              <a:t>• AI Pipeline: Google Gemini 2.5 Flash + DuckDuckGo live search api.</a:t>
             </a:r>
           </a:p>
           <a:p>
@@ -6779,7 +5536,7 @@
               </a:defRPr>
             </a:pPr>
             <a:r>
-              <a:t>• Action-Oriented: Every plan centers around a realistic, immediate Day 1 validation task.</a:t>
+              <a:t>• Traction: Deployed on Vercel. 30/60/90 roadmap targets user accounts and voice integration.</a:t>
             </a:r>
           </a:p>
         </p:txBody>
@@ -6877,7 +5634,7 @@
               </a:defRPr>
             </a:pPr>
             <a:r>
-              <a:t>Technical Architecture</a:t>
+              <a:t>Business Model &amp; Team</a:t>
             </a:r>
           </a:p>
         </p:txBody>
@@ -6913,7 +5670,7 @@
               </a:defRPr>
             </a:pPr>
             <a:r>
-              <a:t>Built for speed, safety, and scale.</a:t>
+              <a:t>Team Dynamic Duo — Curing the Builder's Blindspot.</a:t>
             </a:r>
           </a:p>
         </p:txBody>
@@ -6953,7 +5710,7 @@
               </a:defRPr>
             </a:pPr>
             <a:r>
-              <a:t>• Frontend: React SPA using Vite, TypeScript, TailwindCSS, and Framer Motion animations.</a:t>
+              <a:t>• Freemium Model: 3 free validations/month, Pro plan ($19/mo) for unlimited validations.</a:t>
             </a:r>
           </a:p>
           <a:p>
@@ -6969,7 +5726,7 @@
               </a:defRPr>
             </a:pPr>
             <a:r>
-              <a:t>• Backend: FastAPI (Python) asynchronous REST API endpoints.</a:t>
+              <a:t>• Swaraj Kumar Behera — Fullstack Developer &amp; AI Integration Specialist.</a:t>
             </a:r>
           </a:p>
           <a:p>
@@ -6985,7 +5742,7 @@
               </a:defRPr>
             </a:pPr>
             <a:r>
-              <a:t>• AI Pipeline: Google Gemini 2.5 Flash with structured JSON output templates.</a:t>
+              <a:t>• Prajakta Kuila — Frontend Engineer &amp; Lead UI/UX Designer.</a:t>
             </a:r>
           </a:p>
           <a:p>
@@ -7001,229 +5758,7 @@
               </a:defRPr>
             </a:pPr>
             <a:r>
-              <a:t>• Integrations: DuckDuckGo live search api wrapper for competitor mining.</a:t>
-            </a:r>
-          </a:p>
-        </p:txBody>
-      </p:sp>
-    </p:spTree>
-  </p:cSld>
-  <p:clrMapOvr>
-    <a:masterClrMapping/>
-  </p:clrMapOvr>
-</p:sld>
-</file>
-
-<file path=ppt/slides/slide9.xml><?xml version="1.0" encoding="utf-8"?>
-<p:sld xmlns:a="http://schemas.openxmlformats.org/drawingml/2006/main" xmlns:p="http://schemas.openxmlformats.org/presentationml/2006/main" xmlns:r="http://schemas.openxmlformats.org/officeDocument/2006/relationships">
-  <p:cSld>
-    <p:bg>
-      <p:bgPr>
-        <a:solidFill>
-          <a:srgbClr val="0C080D"/>
-        </a:solidFill>
-        <a:effectLst/>
-      </p:bgPr>
-    </p:bg>
-    <p:spTree>
-      <p:nvGrpSpPr>
-        <p:cNvPr id="1" name=""/>
-        <p:cNvGrpSpPr/>
-        <p:nvPr/>
-      </p:nvGrpSpPr>
-      <p:grpSpPr/>
-      <p:sp>
-        <p:nvSpPr>
-          <p:cNvPr id="2" name="TextBox 1"/>
-          <p:cNvSpPr txBox="1"/>
-          <p:nvPr/>
-        </p:nvSpPr>
-        <p:spPr>
-          <a:xfrm>
-            <a:off x="457200" y="365760"/>
-            <a:ext cx="1828800" cy="731520"/>
-          </a:xfrm>
-          <a:prstGeom prst="rect">
-            <a:avLst/>
-          </a:prstGeom>
-          <a:noFill/>
-        </p:spPr>
-        <p:txBody>
-          <a:bodyPr wrap="none">
-            <a:spAutoFit/>
-          </a:bodyPr>
-          <a:lstStyle/>
-          <a:p>
-            <a:pPr>
-              <a:defRPr sz="1400" b="1">
-                <a:solidFill>
-                  <a:srgbClr val="C084FC"/>
-                </a:solidFill>
-                <a:latin typeface="Courier New"/>
-              </a:defRPr>
-            </a:pPr>
-            <a:r>
-              <a:t>// SLIDE 09</a:t>
-            </a:r>
-          </a:p>
-        </p:txBody>
-      </p:sp>
-      <p:sp>
-        <p:nvSpPr>
-          <p:cNvPr id="3" name="TextBox 2"/>
-          <p:cNvSpPr txBox="1"/>
-          <p:nvPr/>
-        </p:nvSpPr>
-        <p:spPr>
-          <a:xfrm>
-            <a:off x="457200" y="731520"/>
-            <a:ext cx="10972800" cy="914400"/>
-          </a:xfrm>
-          <a:prstGeom prst="rect">
-            <a:avLst/>
-          </a:prstGeom>
-          <a:noFill/>
-        </p:spPr>
-        <p:txBody>
-          <a:bodyPr wrap="square">
-            <a:spAutoFit/>
-          </a:bodyPr>
-          <a:lstStyle/>
-          <a:p>
-            <a:pPr>
-              <a:defRPr sz="3600" b="1">
-                <a:solidFill>
-                  <a:srgbClr val="FF2D78"/>
-                </a:solidFill>
-                <a:latin typeface="Arial"/>
-              </a:defRPr>
-            </a:pPr>
-            <a:r>
-              <a:t>Traction &amp; Roadmap</a:t>
-            </a:r>
-          </a:p>
-        </p:txBody>
-      </p:sp>
-      <p:sp>
-        <p:nvSpPr>
-          <p:cNvPr id="4" name="TextBox 3"/>
-          <p:cNvSpPr txBox="1"/>
-          <p:nvPr/>
-        </p:nvSpPr>
-        <p:spPr>
-          <a:xfrm>
-            <a:off x="457200" y="1645920"/>
-            <a:ext cx="10972800" cy="457200"/>
-          </a:xfrm>
-          <a:prstGeom prst="rect">
-            <a:avLst/>
-          </a:prstGeom>
-          <a:noFill/>
-        </p:spPr>
-        <p:txBody>
-          <a:bodyPr wrap="square">
-            <a:spAutoFit/>
-          </a:bodyPr>
-          <a:lstStyle/>
-          <a:p>
-            <a:pPr>
-              <a:defRPr sz="1800" i="1">
-                <a:solidFill>
-                  <a:srgbClr val="C084FC"/>
-                </a:solidFill>
-                <a:latin typeface="Arial"/>
-              </a:defRPr>
-            </a:pPr>
-            <a:r>
-              <a:t>Our execution plan.</a:t>
-            </a:r>
-          </a:p>
-        </p:txBody>
-      </p:sp>
-      <p:sp>
-        <p:nvSpPr>
-          <p:cNvPr id="5" name="TextBox 4"/>
-          <p:cNvSpPr txBox="1"/>
-          <p:nvPr/>
-        </p:nvSpPr>
-        <p:spPr>
-          <a:xfrm>
-            <a:off x="457200" y="2286000"/>
-            <a:ext cx="11274552" cy="3840480"/>
-          </a:xfrm>
-          <a:prstGeom prst="rect">
-            <a:avLst/>
-          </a:prstGeom>
-          <a:noFill/>
-        </p:spPr>
-        <p:txBody>
-          <a:bodyPr wrap="square">
-            <a:spAutoFit/>
-          </a:bodyPr>
-          <a:lstStyle/>
-          <a:p/>
-          <a:p>
-            <a:pPr>
-              <a:spcAft>
-                <a:spcPts val="1400"/>
-              </a:spcAft>
-              <a:defRPr sz="1600">
-                <a:solidFill>
-                  <a:srgbClr val="FFF0F5"/>
-                </a:solidFill>
-                <a:latin typeface="Arial"/>
-              </a:defRPr>
-            </a:pPr>
-            <a:r>
-              <a:t>• Phase 1 (Now): Core validation engine and VC Pitch Room MVP completed.</a:t>
-            </a:r>
-          </a:p>
-          <a:p>
-            <a:pPr>
-              <a:spcAft>
-                <a:spcPts val="1400"/>
-              </a:spcAft>
-              <a:defRPr sz="1600">
-                <a:solidFill>
-                  <a:srgbClr val="FFF0F5"/>
-                </a:solidFill>
-                <a:latin typeface="Arial"/>
-              </a:defRPr>
-            </a:pPr>
-            <a:r>
-              <a:t>• Phase 2 (Q3): User authentication, project dashboard persistence, and progress tracking.</a:t>
-            </a:r>
-          </a:p>
-          <a:p>
-            <a:pPr>
-              <a:spcAft>
-                <a:spcPts val="1400"/>
-              </a:spcAft>
-              <a:defRPr sz="1600">
-                <a:solidFill>
-                  <a:srgbClr val="FFF0F5"/>
-                </a:solidFill>
-                <a:latin typeface="Arial"/>
-              </a:defRPr>
-            </a:pPr>
-            <a:r>
-              <a:t>• Phase 3 (Q4): Voice-to-voice pitch capability and vector-based YC deck benchmark scanning.</a:t>
-            </a:r>
-          </a:p>
-          <a:p>
-            <a:pPr>
-              <a:spcAft>
-                <a:spcPts val="1400"/>
-              </a:spcAft>
-              <a:defRPr sz="1600">
-                <a:solidFill>
-                  <a:srgbClr val="FFF0F5"/>
-                </a:solidFill>
-                <a:latin typeface="Arial"/>
-              </a:defRPr>
-            </a:pPr>
-            <a:r>
-              <a:t>• Target: 10,000 active validations and partnerships with university hackathon organizers.</a:t>
+              <a:t>• GitHub Repository: https://github.com/swaraj3092/LaunchMind</a:t>
             </a:r>
           </a:p>
         </p:txBody>

</xml_diff>